<commit_message>
docs(level5): refresh product proof and audit status
</commit_message>
<xml_diff>
--- a/docs/pitch/AgentRail-Level5-Pitch-Deck.pptx
+++ b/docs/pitch/AgentRail-Level5-Pitch-Deck.pptx
@@ -2,22 +2,22 @@
 <file path=ppt/presentation.xml><?xml version="1.0" encoding="utf-8"?>
 <p:presentation xmlns:p="http://schemas.openxmlformats.org/presentationml/2006/main">
   <p:sldMasterIdLst>
-    <p:sldMasterId xmlns:r="http://schemas.openxmlformats.org/officeDocument/2006/relationships" id="2147483648" r:id="R93c4aee4e8174dbb"/>
+    <p:sldMasterId xmlns:r="http://schemas.openxmlformats.org/officeDocument/2006/relationships" id="2147483648" r:id="Rcbe0944a4fa34b4d"/>
   </p:sldMasterIdLst>
   <p:notesMasterIdLst>
-    <p:notesMasterId xmlns:r="http://schemas.openxmlformats.org/officeDocument/2006/relationships" r:id="R2185ec0f9c66481a"/>
+    <p:notesMasterId xmlns:r="http://schemas.openxmlformats.org/officeDocument/2006/relationships" r:id="R26bfb733e4f24c84"/>
   </p:notesMasterIdLst>
   <p:sldIdLst>
-    <p:sldId xmlns:r="http://schemas.openxmlformats.org/officeDocument/2006/relationships" id="256" r:id="Rc6bf90bc5cb44d3d"/>
-    <p:sldId xmlns:r="http://schemas.openxmlformats.org/officeDocument/2006/relationships" id="257" r:id="R3108d22b4a184135"/>
-    <p:sldId xmlns:r="http://schemas.openxmlformats.org/officeDocument/2006/relationships" id="258" r:id="R92a6174ad330456e"/>
-    <p:sldId xmlns:r="http://schemas.openxmlformats.org/officeDocument/2006/relationships" id="259" r:id="Rd785321630524984"/>
-    <p:sldId xmlns:r="http://schemas.openxmlformats.org/officeDocument/2006/relationships" id="260" r:id="R70dfcbece0804537"/>
-    <p:sldId xmlns:r="http://schemas.openxmlformats.org/officeDocument/2006/relationships" id="261" r:id="R4963d8c4050c4924"/>
-    <p:sldId xmlns:r="http://schemas.openxmlformats.org/officeDocument/2006/relationships" id="262" r:id="Rcb98d77b9db34a7f"/>
-    <p:sldId xmlns:r="http://schemas.openxmlformats.org/officeDocument/2006/relationships" id="263" r:id="R1eec30527fb64633"/>
-    <p:sldId xmlns:r="http://schemas.openxmlformats.org/officeDocument/2006/relationships" id="264" r:id="Rff8d07a264cf4c4e"/>
-    <p:sldId xmlns:r="http://schemas.openxmlformats.org/officeDocument/2006/relationships" id="265" r:id="R0c3fe928c3b940cb"/>
+    <p:sldId xmlns:r="http://schemas.openxmlformats.org/officeDocument/2006/relationships" id="256" r:id="Rb461867877f24298"/>
+    <p:sldId xmlns:r="http://schemas.openxmlformats.org/officeDocument/2006/relationships" id="257" r:id="R1e2035527d7c494d"/>
+    <p:sldId xmlns:r="http://schemas.openxmlformats.org/officeDocument/2006/relationships" id="258" r:id="R8d696c446cb0446a"/>
+    <p:sldId xmlns:r="http://schemas.openxmlformats.org/officeDocument/2006/relationships" id="259" r:id="R5cf3d5da931545dd"/>
+    <p:sldId xmlns:r="http://schemas.openxmlformats.org/officeDocument/2006/relationships" id="260" r:id="R117121adfbd4498a"/>
+    <p:sldId xmlns:r="http://schemas.openxmlformats.org/officeDocument/2006/relationships" id="261" r:id="R2a723a4cb629474d"/>
+    <p:sldId xmlns:r="http://schemas.openxmlformats.org/officeDocument/2006/relationships" id="262" r:id="R4dc488610a984fc5"/>
+    <p:sldId xmlns:r="http://schemas.openxmlformats.org/officeDocument/2006/relationships" id="263" r:id="R5694bbdce3c3475a"/>
+    <p:sldId xmlns:r="http://schemas.openxmlformats.org/officeDocument/2006/relationships" id="264" r:id="Rd420f8d79d34437e"/>
+    <p:sldId xmlns:r="http://schemas.openxmlformats.org/officeDocument/2006/relationships" id="265" r:id="R500007e3a55f45ab"/>
   </p:sldIdLst>
   <p:sldSz cx="12192000" cy="6858000"/>
   <p:notesSz cx="6858000" cy="9144000"/>
@@ -1329,7 +1329,7 @@
   </p:cSld>
   <p:clrMap bg1="lt1" tx1="dk1" bg2="lt2" tx2="dk2" accent1="accent1" accent2="accent2" accent3="accent3" accent4="accent4" accent5="accent5" accent6="accent6" hlink="hlink" folHlink="folHlink"/>
   <p:sldLayoutIdLst>
-    <p:sldLayoutId xmlns:r="http://schemas.openxmlformats.org/officeDocument/2006/relationships" id="2147483649" r:id="R19af09edda0c4271"/>
+    <p:sldLayoutId xmlns:r="http://schemas.openxmlformats.org/officeDocument/2006/relationships" id="2147483649" r:id="R5cf21d7515714ea5"/>
   </p:sldLayoutIdLst>
   <p:txStyles>
     <p:titleStyle>
@@ -2147,18 +2147,16 @@
           <p:nvPr/>
         </p:nvPicPr>
         <p:blipFill>
-          <a:blip xmlns:r="http://schemas.openxmlformats.org/officeDocument/2006/relationships" xmlns:a="http://schemas.openxmlformats.org/drawingml/2006/main" r:embed="Rb49801848c0940b6"/>
+          <a:blip xmlns:r="http://schemas.openxmlformats.org/officeDocument/2006/relationships" xmlns:a="http://schemas.openxmlformats.org/drawingml/2006/main" r:embed="R905df3b77d174744"/>
           <a:stretch xmlns:a="http://schemas.openxmlformats.org/drawingml/2006/main"/>
         </p:blipFill>
         <p:spPr>
-          <a:xfrm xmlns:a="http://schemas.openxmlformats.org/drawingml/2006/main">
+          <a:xfrm xmlns:a="http://schemas.openxmlformats.org/drawingml/2006/main" flipH="0" flipV="0">
             <a:off x="7755239" y="400050"/>
             <a:ext cx="2587022" cy="5600700"/>
           </a:xfrm>
           <a:prstGeom xmlns:a="http://schemas.openxmlformats.org/drawingml/2006/main" prst="roundRect">
-            <a:avLst>
-              <a:gd name="adj" fmla="val 2069"/>
-            </a:avLst>
+            <a:avLst/>
           </a:prstGeom>
         </p:spPr>
       </p:pic>
@@ -3937,21 +3935,19 @@
           <p:nvPr/>
         </p:nvPicPr>
         <p:blipFill>
-          <a:blip xmlns:r="http://schemas.openxmlformats.org/officeDocument/2006/relationships" xmlns:a="http://schemas.openxmlformats.org/drawingml/2006/main" r:embed="R8724d98ef6f64c67"/>
+          <a:blip xmlns:r="http://schemas.openxmlformats.org/officeDocument/2006/relationships" xmlns:a="http://schemas.openxmlformats.org/drawingml/2006/main" r:embed="R7e9d29ae5d4a418e"/>
           <a:srcRect xmlns:a="http://schemas.openxmlformats.org/drawingml/2006/main" l="8391" t="0" r="8391" b="0"/>
           <a:stretch xmlns:a="http://schemas.openxmlformats.org/drawingml/2006/main">
             <a:fillRect l="0" t="0" r="0" b="0"/>
           </a:stretch>
         </p:blipFill>
         <p:spPr>
-          <a:xfrm xmlns:a="http://schemas.openxmlformats.org/drawingml/2006/main">
+          <a:xfrm xmlns:a="http://schemas.openxmlformats.org/drawingml/2006/main" flipH="0" flipV="0">
             <a:off x="6286500" y="1390650"/>
             <a:ext cx="5524500" cy="4610100"/>
           </a:xfrm>
           <a:prstGeom xmlns:a="http://schemas.openxmlformats.org/drawingml/2006/main" prst="roundRect">
-            <a:avLst>
-              <a:gd name="adj" fmla="val 2479"/>
-            </a:avLst>
+            <a:avLst/>
           </a:prstGeom>
         </p:spPr>
       </p:pic>
@@ -4315,7 +4311,7 @@
           <p:nvPr/>
         </p:nvPicPr>
         <p:blipFill>
-          <a:blip xmlns:r="http://schemas.openxmlformats.org/officeDocument/2006/relationships" xmlns:a="http://schemas.openxmlformats.org/drawingml/2006/main" r:embed="R42b28e7c9a1e4cc2"/>
+          <a:blip xmlns:r="http://schemas.openxmlformats.org/officeDocument/2006/relationships" xmlns:a="http://schemas.openxmlformats.org/drawingml/2006/main" r:embed="R8232fc2009ac48ae"/>
           <a:srcRect xmlns:a="http://schemas.openxmlformats.org/drawingml/2006/main" l="3724" t="0" r="3724" b="0"/>
           <a:stretch xmlns:a="http://schemas.openxmlformats.org/drawingml/2006/main">
             <a:fillRect l="0" t="0" r="0" b="0"/>
@@ -4476,7 +4472,7 @@
       </p:sp>
       <p:cxnSp>
         <p:nvCxnSpPr>
-          <p:cNvPr id="37" name="arch-edge-0"/>
+          <p:cNvPr id="49" name="arch-edge-0"/>
           <p:cNvCxnSpPr/>
           <p:nvPr/>
         </p:nvCxnSpPr>
@@ -4498,7 +4494,7 @@
       </p:cxnSp>
       <p:cxnSp>
         <p:nvCxnSpPr>
-          <p:cNvPr id="38" name="arch-edge-1"/>
+          <p:cNvPr id="50" name="arch-edge-1"/>
           <p:cNvCxnSpPr/>
           <p:nvPr/>
         </p:nvCxnSpPr>
@@ -4520,7 +4516,7 @@
       </p:cxnSp>
       <p:cxnSp>
         <p:nvCxnSpPr>
-          <p:cNvPr id="39" name="arch-edge-2"/>
+          <p:cNvPr id="51" name="arch-edge-2"/>
           <p:cNvCxnSpPr/>
           <p:nvPr/>
         </p:nvCxnSpPr>
@@ -4542,7 +4538,7 @@
       </p:cxnSp>
       <p:cxnSp>
         <p:nvCxnSpPr>
-          <p:cNvPr id="40" name="arch-edge-3"/>
+          <p:cNvPr id="52" name="arch-edge-3"/>
           <p:cNvCxnSpPr/>
           <p:nvPr/>
         </p:nvCxnSpPr>
@@ -5749,7 +5745,7 @@
                 <a:ea typeface="Helvetica Neue"/>
                 <a:cs typeface="Helvetica Neue"/>
               </a:rPr>
-              <a:t>6</a:t>
+              <a:t>57</a:t>
             </a:r>
           </a:p>
         </p:txBody>
@@ -6250,7 +6246,7 @@
       </p:sp>
       <p:cxnSp>
         <p:nvCxnSpPr>
-          <p:cNvPr id="24" name="growth-line"/>
+          <p:cNvPr id="30" name="growth-line"/>
           <p:cNvCxnSpPr/>
           <p:nvPr/>
         </p:nvCxnSpPr>

</xml_diff>